<commit_message>
Eliminate white bar artifacts using native theme-adaptive widgets and update all documentation to live Streamlit Cloud URL
</commit_message>
<xml_diff>
--- a/Olympic_Team_Performance_Presentation.pptx
+++ b/Olympic_Team_Performance_Presentation.pptx
@@ -3150,8 +3150,8 @@
         </p:nvSpPr>
         <p:spPr>
           <a:xfrm>
-            <a:off x="1097280" y="1645920"/>
-            <a:ext cx="10058400" cy="3657600"/>
+            <a:off x="1097280" y="1371600"/>
+            <a:ext cx="10058400" cy="4114800"/>
           </a:xfrm>
           <a:prstGeom prst="rect">
             <a:avLst/>
@@ -3178,7 +3178,7 @@
           <a:p>
             <a:pPr>
               <a:spcBef>
-                <a:spcPts val="1000"/>
+                <a:spcPts val="800"/>
               </a:spcBef>
               <a:defRPr sz="3600" b="1">
                 <a:solidFill>
@@ -3195,7 +3195,7 @@
               <a:spcBef>
                 <a:spcPts val="400"/>
               </a:spcBef>
-              <a:defRPr sz="2600" b="0">
+              <a:defRPr sz="2400" b="0">
                 <a:solidFill>
                   <a:srgbClr val="CBD5E1"/>
                 </a:solidFill>
@@ -3208,9 +3208,9 @@
           <a:p>
             <a:pPr>
               <a:spcBef>
-                <a:spcPts val="2400"/>
+                <a:spcPts val="1800"/>
               </a:spcBef>
-              <a:defRPr sz="1400">
+              <a:defRPr sz="1300">
                 <a:solidFill>
                   <a:srgbClr val="94A3B8"/>
                 </a:solidFill>
@@ -3223,16 +3223,16 @@
           <a:p>
             <a:pPr>
               <a:spcBef>
-                <a:spcPts val="3000"/>
+                <a:spcPts val="2000"/>
               </a:spcBef>
-              <a:defRPr sz="1100">
-                <a:solidFill>
-                  <a:srgbClr val="CBD5E1"/>
-                </a:solidFill>
-              </a:defRPr>
-            </a:pPr>
-            <a:r>
-              <a:t>Methodology: Random Forest (MDI &amp; Permutation) | Normal R2 Evaluation | Modern Summer Games (1960-2016)</a:t>
+              <a:defRPr sz="1200" b="1">
+                <a:solidFill>
+                  <a:srgbClr val="60A5FA"/>
+                </a:solidFill>
+              </a:defRPr>
+            </a:pPr>
+            <a:r>
+              <a:t>Live Streamlit Cloud Deployment: https://virshin1-team-performance-analysis-app-kwvw1u.streamlit.app/</a:t>
             </a:r>
           </a:p>
         </p:txBody>
@@ -3942,7 +3942,7 @@
               </a:defRPr>
             </a:pPr>
             <a:r>
-              <a:t>Limitation 2: Delegation-Level Aggregation Aggregation Loss</a:t>
+              <a:t>Limitation 2: Delegation-Level Aggregation Loss</a:t>
             </a:r>
           </a:p>
           <a:p>
@@ -4226,8 +4226,8 @@
         </p:nvSpPr>
         <p:spPr>
           <a:xfrm>
-            <a:off x="1097280" y="1280160"/>
-            <a:ext cx="10058400" cy="4572000"/>
+            <a:off x="1097280" y="1097280"/>
+            <a:ext cx="10058400" cy="4754880"/>
           </a:xfrm>
           <a:prstGeom prst="rect">
             <a:avLst/>
@@ -4269,7 +4269,7 @@
           <a:p>
             <a:pPr>
               <a:spcBef>
-                <a:spcPts val="1400"/>
+                <a:spcPts val="1200"/>
               </a:spcBef>
               <a:defRPr b="1" sz="1300">
                 <a:solidFill>
@@ -4292,7 +4292,7 @@
           <a:p>
             <a:pPr>
               <a:spcBef>
-                <a:spcPts val="1400"/>
+                <a:spcPts val="1200"/>
               </a:spcBef>
               <a:defRPr b="1" sz="1300">
                 <a:solidFill>
@@ -4315,7 +4315,7 @@
           <a:p>
             <a:pPr>
               <a:spcBef>
-                <a:spcPts val="1400"/>
+                <a:spcPts val="1200"/>
               </a:spcBef>
               <a:defRPr b="1" sz="1300">
                 <a:solidFill>
@@ -4338,7 +4338,7 @@
           <a:p>
             <a:pPr>
               <a:spcBef>
-                <a:spcPts val="1400"/>
+                <a:spcPts val="1200"/>
               </a:spcBef>
               <a:defRPr b="1" sz="1300">
                 <a:solidFill>
@@ -4347,7 +4347,7 @@
               </a:defRPr>
             </a:pPr>
             <a:r>
-              <a:t>Production Artifacts: </a:t>
+              <a:t>Live Cloud Application: </a:t>
             </a:r>
             <a:r>
               <a:rPr b="0">
@@ -4355,7 +4355,7 @@
                   <a:srgbClr val="E2E8F0"/>
                 </a:solidFill>
               </a:rPr>
-              <a:t>Complete pipeline delivered with fully executed Jupyter notebook, clean standalone GitHub repo, and live Streamlit dashboard on http://localhost:8501.</a:t>
+              <a:t>Production application deployed live on Streamlit Cloud: https://virshin1-team-performance-analysis-app-kwvw1u.streamlit.app/ (accessible anywhere).</a:t>
             </a:r>
           </a:p>
         </p:txBody>
@@ -4796,7 +4796,7 @@
               </a:defRPr>
             </a:pPr>
             <a:r>
-              <a:t>Interactive Streamlit App: </a:t>
+              <a:t>Live Cloud Application: </a:t>
             </a:r>
             <a:r>
               <a:rPr b="0">
@@ -4804,7 +4804,7 @@
                   <a:srgbClr val="475569"/>
                 </a:solidFill>
               </a:rPr>
-              <a:t>Production-grade wide dashboard allowing scenario simulations and live factor diagnostics against Olympic benchmarks.</a:t>
+              <a:t>Production-grade wide dashboard deployed live on Streamlit Community Cloud with interactive scenario simulation.</a:t>
             </a:r>
           </a:p>
         </p:txBody>
@@ -5326,7 +5326,7 @@
                   <a:srgbClr val="475569"/>
                 </a:solidFill>
               </a:rPr>
-              <a:t>Extracted from historical Olympic archives covering all modern Summer Olympiads, encompassing over 200,000 individual competitor-event records.</a:t>
+              <a:t>Extracted from historical Olympic archives covering all modern Summer Olympiads, encompassing over 200,000 competitor records.</a:t>
             </a:r>
           </a:p>
           <a:p>
@@ -5349,7 +5349,7 @@
                   <a:srgbClr val="475569"/>
                 </a:solidFill>
               </a:rPr>
-              <a:t>Crucial Sports Rule: In team events (e.g., Football 18 players, Rowing 8 crew), all players receive medals, but the delegation only wins ONE official medal. Deduplicated strictly to (Games, Year, Event, Medal).</a:t>
+              <a:t>Crucial Sports Rule: In team events (e.g. Football 18 players), all receive medals, but the delegation wins ONE official medal. Deduplicated strictly to (Games, Year, Event, Medal).</a:t>
             </a:r>
           </a:p>
           <a:p>
@@ -5372,7 +5372,7 @@
                   <a:srgbClr val="475569"/>
                 </a:solidFill>
               </a:rPr>
-              <a:t>Consolidated to the delegation level per Olympic Games (NOC, Year). Features capture scale, discipline diversity, demographic distributions, and temporal momentum.</a:t>
+              <a:t>Consolidated to the delegation level per Olympic Games (NOC, Year). Captures scale, diversity, demographic distributions, and momentum.</a:t>
             </a:r>
           </a:p>
           <a:p>
@@ -5395,7 +5395,7 @@
                   <a:srgbClr val="475569"/>
                 </a:solidFill>
               </a:rPr>
-              <a:t>Missing height/weight records for early games imputed using discipline-gender median baselines rather than global means, preserving authentic sports body-type distributions.</a:t>
+              <a:t>Missing height/weight records for early games imputed using discipline-gender median baselines rather than global means.</a:t>
             </a:r>
           </a:p>
           <a:p>
@@ -5418,7 +5418,7 @@
                   <a:srgbClr val="475569"/>
                 </a:solidFill>
               </a:rPr>
-              <a:t>Engineered prev_medals: Total medals achieved in the prior Olympic cycle for that specific nation, capturing institutional funding and coaching pipeline continuity.</a:t>
+              <a:t>Engineered prev_medals: Total medals achieved in the prior Olympic cycle for that nation, capturing institutional funding continuity.</a:t>
             </a:r>
           </a:p>
         </p:txBody>
@@ -5713,7 +5713,7 @@
               </a:defRPr>
             </a:pPr>
             <a:r>
-              <a:t>Distinct sports disciplines contested (Athletics, Aquatics, etc.) (Range: 1 to 32)</a:t>
+              <a:t>Distinct sports disciplines contested (Range: 1 to 32)</a:t>
             </a:r>
           </a:p>
         </p:txBody>
@@ -6289,7 +6289,7 @@
                   <a:srgbClr val="475569"/>
                 </a:solidFill>
               </a:rPr>
-              <a:t>Athlete biometrics (mean_age r=+0.012, mean_bmi r=-0.006) show virtually zero linear correlation because optimal body types vary dramatically across sports (e.g. Gymnastics vs Shot Put).</a:t>
+              <a:t>Athlete biometrics (mean_age r=+0.012, mean_bmi r=-0.006) show virtually zero linear correlation because optimal body types vary dramatically across sports.</a:t>
             </a:r>
           </a:p>
         </p:txBody>
@@ -8856,7 +8856,7 @@
               </a:defRPr>
             </a:pPr>
             <a:r>
-              <a:t>1. Benchmark Scenario Engine</a:t>
+              <a:t>1. Live Cloud Deployment</a:t>
             </a:r>
           </a:p>
           <a:p>
@@ -8868,7 +8868,7 @@
               </a:defRPr>
             </a:pPr>
             <a:r>
-              <a:t>Includes 1-click preset profiles for rapid testing: Global Powerhouse (USA/China), Mid-Tier Contender (Netherlands/Brazil), and Emerging Delegation. Enables examiners to immediately test realistic profiles.</a:t>
+              <a:t>Deployed live on Streamlit Community Cloud: https://virshin1-team-performance-analysis-app-kwvw1u.streamlit.app/ - accessible globally with zero local installation required.</a:t>
             </a:r>
           </a:p>
         </p:txBody>
@@ -8922,7 +8922,7 @@
               </a:defRPr>
             </a:pPr>
             <a:r>
-              <a:t>2. Wide Dashboard Layout</a:t>
+              <a:t>2. Benchmark Scenario Engine</a:t>
             </a:r>
           </a:p>
           <a:p>
@@ -8934,7 +8934,7 @@
               </a:defRPr>
             </a:pPr>
             <a:r>
-              <a:t>Configured with st.set_page_config(layout='wide') separating user parameter controls in the left sidebar from real-time analytics in the main canvas.</a:t>
+              <a:t>Includes 1-click preset profiles for rapid testing: Global Powerhouse (USA/China), Mid-Tier Contender (Netherlands/Brazil), and Emerging Delegation. Enables examiners to immediately test realistic profiles.</a:t>
             </a:r>
           </a:p>
         </p:txBody>
@@ -8988,7 +8988,7 @@
               </a:defRPr>
             </a:pPr>
             <a:r>
-              <a:t>3. Dual Model Inference Engine</a:t>
+              <a:t>3. Wide Dashboard Layout</a:t>
             </a:r>
           </a:p>
           <a:p>
@@ -9000,7 +9000,7 @@
               </a:defRPr>
             </a:pPr>
             <a:r>
-              <a:t>Simultaneously executes Random Forest classification for podium probability and Gradient Boosting regression for exact medal count forecasting.</a:t>
+              <a:t>Configured with st.set_page_config(layout='wide') separating user parameter controls in the left sidebar from real-time analytics in the main canvas.</a:t>
             </a:r>
           </a:p>
         </p:txBody>
@@ -9054,7 +9054,7 @@
               </a:defRPr>
             </a:pPr>
             <a:r>
-              <a:t>4. Visual Probability Breakdown</a:t>
+              <a:t>4. Dual Model Inference Engine</a:t>
             </a:r>
           </a:p>
           <a:p>
@@ -9066,7 +9066,7 @@
               </a:defRPr>
             </a:pPr>
             <a:r>
-              <a:t>Dynamic Altair probability bar visualizing confidence spread between non-podium and medal-winning outcomes.</a:t>
+              <a:t>Simultaneously executes Random Forest classification for podium probability and Gradient Boosting regression for exact medal count forecasting.</a:t>
             </a:r>
           </a:p>
         </p:txBody>
@@ -9132,7 +9132,7 @@
               </a:defRPr>
             </a:pPr>
             <a:r>
-              <a:t>Compares user-configured inputs directly against historical medians of medal-winning vs non-winning Olympic teams.</a:t>
+              <a:t>Compares user-configured inputs directly against historical medians of medal-winning vs non-winning Olympic teams using responsive, theme-adaptive dataframes.</a:t>
             </a:r>
           </a:p>
         </p:txBody>

</xml_diff>

<commit_message>
Update last slide of presentation to clean professional closing slide
</commit_message>
<xml_diff>
--- a/Olympic_Team_Performance_Presentation.pptx
+++ b/Olympic_Team_Performance_Presentation.pptx
@@ -4226,8 +4226,8 @@
         </p:nvSpPr>
         <p:spPr>
           <a:xfrm>
-            <a:off x="1097280" y="1097280"/>
-            <a:ext cx="10058400" cy="4754880"/>
+            <a:off x="1097280" y="1645920"/>
+            <a:ext cx="10058400" cy="4114800"/>
           </a:xfrm>
           <a:prstGeom prst="rect">
             <a:avLst/>
@@ -4248,7 +4248,22 @@
               </a:defRPr>
             </a:pPr>
             <a:r>
-              <a:t>PROJECT SUMMARY &amp; VIVA READINESS</a:t>
+              <a:t>CASE STUDY: TEAM PERFORMANCE ANALYSIS</a:t>
+            </a:r>
+          </a:p>
+          <a:p>
+            <a:pPr>
+              <a:spcBef>
+                <a:spcPts val="800"/>
+              </a:spcBef>
+              <a:defRPr sz="4000" b="1">
+                <a:solidFill>
+                  <a:srgbClr val="FFFFFF"/>
+                </a:solidFill>
+              </a:defRPr>
+            </a:pPr>
+            <a:r>
+              <a:t>Thank You</a:t>
             </a:r>
           </a:p>
           <a:p>
@@ -4256,106 +4271,52 @@
               <a:spcBef>
                 <a:spcPts val="600"/>
               </a:spcBef>
-              <a:defRPr sz="2800" b="1">
-                <a:solidFill>
-                  <a:srgbClr val="FFFFFF"/>
-                </a:solidFill>
-              </a:defRPr>
-            </a:pPr>
-            <a:r>
-              <a:t>Key Takeaways for Examination Defense</a:t>
+              <a:defRPr sz="2000">
+                <a:solidFill>
+                  <a:srgbClr val="CBD5E1"/>
+                </a:solidFill>
+              </a:defRPr>
+            </a:pPr>
+            <a:r>
+              <a:t>Questions &amp; Examination Defense</a:t>
             </a:r>
           </a:p>
           <a:p>
             <a:pPr>
               <a:spcBef>
-                <a:spcPts val="1200"/>
+                <a:spcPts val="2000"/>
               </a:spcBef>
-              <a:defRPr b="1" sz="1300">
-                <a:solidFill>
-                  <a:srgbClr val="FEF08A"/>
-                </a:solidFill>
-              </a:defRPr>
-            </a:pPr>
-            <a:r>
-              <a:t>Defensible Model Choice: </a:t>
-            </a:r>
-            <a:r>
-              <a:rPr b="0">
-                <a:solidFill>
-                  <a:srgbClr val="E2E8F0"/>
-                </a:solidFill>
-              </a:rPr>
-              <a:t>Random Forest selected for non-linear threshold handling, outlier robustness on skewed sports distributions, and intrinsic Gini importance attribution.</a:t>
+              <a:defRPr sz="1300">
+                <a:solidFill>
+                  <a:srgbClr val="94A3B8"/>
+                </a:solidFill>
+              </a:defRPr>
+            </a:pPr>
+            <a:r>
+              <a:t>Candidate: R Virshin | Roll No: 150096724147</a:t>
+            </a:r>
+            <a:br/>
+            <a:r>
+              <a:t>ITM Skills University | School of Future Tech | B.Tech CSE Semester V</a:t>
             </a:r>
           </a:p>
           <a:p>
             <a:pPr>
               <a:spcBef>
-                <a:spcPts val="1200"/>
+                <a:spcPts val="1800"/>
               </a:spcBef>
-              <a:defRPr b="1" sz="1300">
-                <a:solidFill>
-                  <a:srgbClr val="FEF08A"/>
-                </a:solidFill>
-              </a:defRPr>
-            </a:pPr>
-            <a:r>
-              <a:t>Clear Answer to Problem Statement: </a:t>
-            </a:r>
-            <a:r>
-              <a:rPr b="0">
-                <a:solidFill>
-                  <a:srgbClr val="E2E8F0"/>
-                </a:solidFill>
-              </a:rPr>
-              <a:t>Roster scale and discipline diversity account for 78.9% of predictive power; past momentum accounts for 11.3%; biometrics provide only 9.8% fine-tuning.</a:t>
-            </a:r>
-          </a:p>
-          <a:p>
-            <a:pPr>
-              <a:spcBef>
-                <a:spcPts val="1200"/>
-              </a:spcBef>
-              <a:defRPr b="1" sz="1300">
-                <a:solidFill>
-                  <a:srgbClr val="FEF08A"/>
-                </a:solidFill>
-              </a:defRPr>
-            </a:pPr>
-            <a:r>
-              <a:t>Sound Evaluation: </a:t>
-            </a:r>
-            <a:r>
-              <a:rPr b="0">
-                <a:solidFill>
-                  <a:srgbClr val="E2E8F0"/>
-                </a:solidFill>
-              </a:rPr>
-              <a:t>Evaluated strictly using normal Train R2 (0.9863) and Test R2 (0.8838) without cross-validation R2 averaging, and 90.51% classification accuracy.</a:t>
-            </a:r>
-          </a:p>
-          <a:p>
-            <a:pPr>
-              <a:spcBef>
-                <a:spcPts val="1200"/>
-              </a:spcBef>
-              <a:defRPr b="1" sz="1300">
-                <a:solidFill>
-                  <a:srgbClr val="FEF08A"/>
-                </a:solidFill>
-              </a:defRPr>
-            </a:pPr>
-            <a:r>
-              <a:t>Live Cloud Application: </a:t>
-            </a:r>
-            <a:r>
-              <a:rPr b="0">
-                <a:solidFill>
-                  <a:srgbClr val="E2E8F0"/>
-                </a:solidFill>
-              </a:rPr>
-              <a:t>Production application deployed live on Streamlit Cloud: https://virshin1-team-performance-analysis-app-kwvw1u.streamlit.app/ (accessible anywhere).</a:t>
+              <a:defRPr sz="1200" b="1">
+                <a:solidFill>
+                  <a:srgbClr val="60A5FA"/>
+                </a:solidFill>
+              </a:defRPr>
+            </a:pPr>
+            <a:r>
+              <a:t>Live Streamlit Cloud Deployment: https://virshin1-team-performance-analysis-app-kwvw1u.streamlit.app/</a:t>
+            </a:r>
+            <a:br/>
+            <a:r>
+              <a:t>GitHub Source: https://github.com/Virshin1/Team-Performance-Analysis</a:t>
             </a:r>
           </a:p>
         </p:txBody>

</xml_diff>

<commit_message>
Eliminate white box shape fills from presentation and remove examination defense wording from all deliverables
</commit_message>
<xml_diff>
--- a/Olympic_Team_Performance_Presentation.pptx
+++ b/Olympic_Team_Performance_Presentation.pptx
@@ -3172,7 +3172,7 @@
               </a:defRPr>
             </a:pPr>
             <a:r>
-              <a:t>ACADEMIC MACHINE LEARNING PROJECT &amp; VIVA DEFENSE</a:t>
+              <a:t>ACADEMIC MACHINE LEARNING PROJECT</a:t>
             </a:r>
           </a:p>
           <a:p>
@@ -3289,7 +3289,7 @@
             <a:avLst/>
           </a:prstGeom>
           <a:solidFill>
-            <a:srgbClr val="F8FAFC"/>
+            <a:srgbClr val="FFFFFF"/>
           </a:solidFill>
           <a:ln>
             <a:noFill/>
@@ -3402,11 +3402,11 @@
             <a:avLst/>
           </a:prstGeom>
           <a:solidFill>
-            <a:srgbClr val="CBD5E1"/>
+            <a:srgbClr val="E2E8F0"/>
           </a:solidFill>
           <a:ln>
             <a:solidFill>
-              <a:srgbClr val="CBD5E1"/>
+              <a:srgbClr val="E2E8F0"/>
             </a:solidFill>
           </a:ln>
         </p:spPr>
@@ -3446,10 +3446,8 @@
           <a:prstGeom prst="roundRect">
             <a:avLst/>
           </a:prstGeom>
-          <a:solidFill>
-            <a:srgbClr val="FFFFFF"/>
-          </a:solidFill>
-          <a:ln>
+          <a:noFill/>
+          <a:ln w="12700">
             <a:solidFill>
               <a:srgbClr val="CBD5E1"/>
             </a:solidFill>
@@ -3554,10 +3552,8 @@
           <a:prstGeom prst="roundRect">
             <a:avLst/>
           </a:prstGeom>
-          <a:solidFill>
-            <a:srgbClr val="FFFFFF"/>
-          </a:solidFill>
-          <a:ln>
+          <a:noFill/>
+          <a:ln w="12700">
             <a:solidFill>
               <a:srgbClr val="CBD5E1"/>
             </a:solidFill>
@@ -3662,10 +3658,8 @@
           <a:prstGeom prst="roundRect">
             <a:avLst/>
           </a:prstGeom>
-          <a:solidFill>
-            <a:srgbClr val="FFFFFF"/>
-          </a:solidFill>
-          <a:ln>
+          <a:noFill/>
+          <a:ln w="12700">
             <a:solidFill>
               <a:srgbClr val="CBD5E1"/>
             </a:solidFill>
@@ -3789,7 +3783,7 @@
             <a:avLst/>
           </a:prstGeom>
           <a:solidFill>
-            <a:srgbClr val="F8FAFC"/>
+            <a:srgbClr val="FFFFFF"/>
           </a:solidFill>
           <a:ln>
             <a:noFill/>
@@ -3902,11 +3896,11 @@
             <a:avLst/>
           </a:prstGeom>
           <a:solidFill>
-            <a:srgbClr val="CBD5E1"/>
+            <a:srgbClr val="E2E8F0"/>
           </a:solidFill>
           <a:ln>
             <a:solidFill>
-              <a:srgbClr val="CBD5E1"/>
+              <a:srgbClr val="E2E8F0"/>
             </a:solidFill>
           </a:ln>
         </p:spPr>
@@ -3946,10 +3940,8 @@
           <a:prstGeom prst="roundRect">
             <a:avLst/>
           </a:prstGeom>
-          <a:solidFill>
-            <a:srgbClr val="FFFFFF"/>
-          </a:solidFill>
-          <a:ln>
+          <a:noFill/>
+          <a:ln w="12700">
             <a:solidFill>
               <a:srgbClr val="CBD5E1"/>
             </a:solidFill>
@@ -4012,10 +4004,8 @@
           <a:prstGeom prst="roundRect">
             <a:avLst/>
           </a:prstGeom>
-          <a:solidFill>
-            <a:srgbClr val="FFFFFF"/>
-          </a:solidFill>
-          <a:ln>
+          <a:noFill/>
+          <a:ln w="12700">
             <a:solidFill>
               <a:srgbClr val="CBD5E1"/>
             </a:solidFill>
@@ -4078,10 +4068,8 @@
           <a:prstGeom prst="roundRect">
             <a:avLst/>
           </a:prstGeom>
-          <a:solidFill>
-            <a:srgbClr val="FFFFFF"/>
-          </a:solidFill>
-          <a:ln>
+          <a:noFill/>
+          <a:ln w="12700">
             <a:solidFill>
               <a:srgbClr val="CBD5E1"/>
             </a:solidFill>
@@ -4144,10 +4132,8 @@
           <a:prstGeom prst="roundRect">
             <a:avLst/>
           </a:prstGeom>
-          <a:solidFill>
-            <a:srgbClr val="FFFFFF"/>
-          </a:solidFill>
-          <a:ln>
+          <a:noFill/>
+          <a:ln w="12700">
             <a:solidFill>
               <a:srgbClr val="CBD5E1"/>
             </a:solidFill>
@@ -4210,10 +4196,8 @@
           <a:prstGeom prst="roundRect">
             <a:avLst/>
           </a:prstGeom>
-          <a:solidFill>
-            <a:srgbClr val="FFFFFF"/>
-          </a:solidFill>
-          <a:ln>
+          <a:noFill/>
+          <a:ln w="12700">
             <a:solidFill>
               <a:srgbClr val="CBD5E1"/>
             </a:solidFill>
@@ -4331,7 +4315,7 @@
         </p:nvSpPr>
         <p:spPr>
           <a:xfrm>
-            <a:off x="1097280" y="1463040"/>
+            <a:off x="1097280" y="1645920"/>
             <a:ext cx="10058400" cy="4114800"/>
           </a:xfrm>
           <a:prstGeom prst="rect">
@@ -4361,7 +4345,7 @@
               <a:spcBef>
                 <a:spcPts val="800"/>
               </a:spcBef>
-              <a:defRPr sz="4000" b="1">
+              <a:defRPr sz="4400" b="1">
                 <a:solidFill>
                   <a:srgbClr val="FFFFFF"/>
                 </a:solidFill>
@@ -4383,13 +4367,13 @@
               </a:defRPr>
             </a:pPr>
             <a:r>
-              <a:t>Questions &amp; Examination Defense Discussion</a:t>
+              <a:t>Team Performance Analysis - Olympic Machine Learning</a:t>
             </a:r>
           </a:p>
           <a:p>
             <a:pPr>
               <a:spcBef>
-                <a:spcPts val="2000"/>
+                <a:spcPts val="2200"/>
               </a:spcBef>
               <a:defRPr sz="1300">
                 <a:solidFill>
@@ -4417,11 +4401,11 @@
               </a:defRPr>
             </a:pPr>
             <a:r>
-              <a:t>Live Streamlit Cloud Deployment: https://virshin1-team-performance-analysis-app-kwvw1u.streamlit.app/</a:t>
+              <a:t>Live Web Application: https://virshin1-team-performance-analysis-app-kwvw1u.streamlit.app/</a:t>
             </a:r>
             <a:br/>
             <a:r>
-              <a:t>GitHub Source Repository: https://github.com/Virshin1/Team-Performance-Analysis</a:t>
+              <a:t>GitHub Source: https://github.com/Virshin1/Team-Performance-Analysis</a:t>
             </a:r>
           </a:p>
         </p:txBody>
@@ -4459,7 +4443,7 @@
             <a:avLst/>
           </a:prstGeom>
           <a:solidFill>
-            <a:srgbClr val="F8FAFC"/>
+            <a:srgbClr val="FFFFFF"/>
           </a:solidFill>
           <a:ln>
             <a:noFill/>
@@ -4572,11 +4556,11 @@
             <a:avLst/>
           </a:prstGeom>
           <a:solidFill>
-            <a:srgbClr val="CBD5E1"/>
+            <a:srgbClr val="E2E8F0"/>
           </a:solidFill>
           <a:ln>
             <a:solidFill>
-              <a:srgbClr val="CBD5E1"/>
+              <a:srgbClr val="E2E8F0"/>
             </a:solidFill>
           </a:ln>
         </p:spPr>
@@ -4616,10 +4600,8 @@
           <a:prstGeom prst="roundRect">
             <a:avLst/>
           </a:prstGeom>
-          <a:solidFill>
-            <a:srgbClr val="FFFFFF"/>
-          </a:solidFill>
-          <a:ln>
+          <a:noFill/>
+          <a:ln w="12700">
             <a:solidFill>
               <a:srgbClr val="CBD5E1"/>
             </a:solidFill>
@@ -4763,10 +4745,8 @@
           <a:prstGeom prst="roundRect">
             <a:avLst/>
           </a:prstGeom>
-          <a:solidFill>
-            <a:srgbClr val="FFFFFF"/>
-          </a:solidFill>
-          <a:ln>
+          <a:noFill/>
+          <a:ln w="12700">
             <a:solidFill>
               <a:srgbClr val="CBD5E1"/>
             </a:solidFill>
@@ -4913,7 +4893,7 @@
                   <a:srgbClr val="334155"/>
                 </a:solidFill>
               </a:rPr>
-              <a:t>Production application deployed on Streamlit Cloud with scenario testing and benchmark comparison tables.</a:t>
+              <a:t>Production-grade wide dashboard deployed live on Streamlit Community Cloud with interactive scenario simulation.</a:t>
             </a:r>
           </a:p>
         </p:txBody>
@@ -4951,7 +4931,7 @@
             <a:avLst/>
           </a:prstGeom>
           <a:solidFill>
-            <a:srgbClr val="F8FAFC"/>
+            <a:srgbClr val="FFFFFF"/>
           </a:solidFill>
           <a:ln>
             <a:noFill/>
@@ -5064,11 +5044,11 @@
             <a:avLst/>
           </a:prstGeom>
           <a:solidFill>
-            <a:srgbClr val="CBD5E1"/>
+            <a:srgbClr val="E2E8F0"/>
           </a:solidFill>
           <a:ln>
             <a:solidFill>
-              <a:srgbClr val="CBD5E1"/>
+              <a:srgbClr val="E2E8F0"/>
             </a:solidFill>
           </a:ln>
         </p:spPr>
@@ -5108,10 +5088,8 @@
           <a:prstGeom prst="roundRect">
             <a:avLst/>
           </a:prstGeom>
-          <a:solidFill>
-            <a:srgbClr val="FFFFFF"/>
-          </a:solidFill>
-          <a:ln>
+          <a:noFill/>
+          <a:ln w="12700">
             <a:solidFill>
               <a:srgbClr val="CBD5E1"/>
             </a:solidFill>
@@ -5186,10 +5164,8 @@
           <a:prstGeom prst="roundRect">
             <a:avLst/>
           </a:prstGeom>
-          <a:solidFill>
-            <a:srgbClr val="FFFFFF"/>
-          </a:solidFill>
-          <a:ln>
+          <a:noFill/>
+          <a:ln w="12700">
             <a:solidFill>
               <a:srgbClr val="CBD5E1"/>
             </a:solidFill>
@@ -5264,10 +5240,8 @@
           <a:prstGeom prst="roundRect">
             <a:avLst/>
           </a:prstGeom>
-          <a:solidFill>
-            <a:srgbClr val="FFFFFF"/>
-          </a:solidFill>
-          <a:ln>
+          <a:noFill/>
+          <a:ln w="12700">
             <a:solidFill>
               <a:srgbClr val="CBD5E1"/>
             </a:solidFill>
@@ -5342,10 +5316,8 @@
           <a:prstGeom prst="roundRect">
             <a:avLst/>
           </a:prstGeom>
-          <a:solidFill>
-            <a:srgbClr val="FFFFFF"/>
-          </a:solidFill>
-          <a:ln>
+          <a:noFill/>
+          <a:ln w="12700">
             <a:solidFill>
               <a:srgbClr val="CBD5E1"/>
             </a:solidFill>
@@ -5420,10 +5392,8 @@
           <a:prstGeom prst="roundRect">
             <a:avLst/>
           </a:prstGeom>
-          <a:solidFill>
-            <a:srgbClr val="FFFFFF"/>
-          </a:solidFill>
-          <a:ln>
+          <a:noFill/>
+          <a:ln w="12700">
             <a:solidFill>
               <a:srgbClr val="CBD5E1"/>
             </a:solidFill>
@@ -5501,7 +5471,7 @@
                   <a:srgbClr val="334155"/>
                 </a:solidFill>
               </a:rPr>
-              <a:t>In team sports (Football, Basketball, Rowing), every squad member receives a physical medal, but the country wins exactly ONE official medal. Deduplicated strictly to unique (Games, Year, Event, Medal) to eliminate 10x-18x artificial medal inflation.</a:t>
+              <a:t>In team sports (Football, Basketball, Rowing), every squad member receives a physical medal, but the country wins exactly ONE official medal. Deduplicated strictly to unique (Games, Year, Event, Medal) tuples before delegation aggregation.</a:t>
             </a:r>
           </a:p>
           <a:p>
@@ -5608,7 +5578,7 @@
             <a:avLst/>
           </a:prstGeom>
           <a:solidFill>
-            <a:srgbClr val="F8FAFC"/>
+            <a:srgbClr val="FFFFFF"/>
           </a:solidFill>
           <a:ln>
             <a:noFill/>
@@ -5721,11 +5691,11 @@
             <a:avLst/>
           </a:prstGeom>
           <a:solidFill>
-            <a:srgbClr val="CBD5E1"/>
+            <a:srgbClr val="E2E8F0"/>
           </a:solidFill>
           <a:ln>
             <a:solidFill>
-              <a:srgbClr val="CBD5E1"/>
+              <a:srgbClr val="E2E8F0"/>
             </a:solidFill>
           </a:ln>
         </p:spPr>
@@ -5765,10 +5735,8 @@
           <a:prstGeom prst="roundRect">
             <a:avLst/>
           </a:prstGeom>
-          <a:solidFill>
-            <a:srgbClr val="FFFFFF"/>
-          </a:solidFill>
-          <a:ln>
+          <a:noFill/>
+          <a:ln w="12700">
             <a:solidFill>
               <a:srgbClr val="CBD5E1"/>
             </a:solidFill>
@@ -5927,10 +5895,8 @@
           <a:prstGeom prst="roundRect">
             <a:avLst/>
           </a:prstGeom>
-          <a:solidFill>
-            <a:srgbClr val="FFFFFF"/>
-          </a:solidFill>
-          <a:ln>
+          <a:noFill/>
+          <a:ln w="12700">
             <a:solidFill>
               <a:srgbClr val="CBD5E1"/>
             </a:solidFill>
@@ -6035,10 +6001,8 @@
           <a:prstGeom prst="roundRect">
             <a:avLst/>
           </a:prstGeom>
-          <a:solidFill>
-            <a:srgbClr val="FFFFFF"/>
-          </a:solidFill>
-          <a:ln>
+          <a:noFill/>
+          <a:ln w="12700">
             <a:solidFill>
               <a:srgbClr val="CBD5E1"/>
             </a:solidFill>
@@ -6243,7 +6207,7 @@
             <a:avLst/>
           </a:prstGeom>
           <a:solidFill>
-            <a:srgbClr val="F8FAFC"/>
+            <a:srgbClr val="FFFFFF"/>
           </a:solidFill>
           <a:ln>
             <a:noFill/>
@@ -6356,11 +6320,11 @@
             <a:avLst/>
           </a:prstGeom>
           <a:solidFill>
-            <a:srgbClr val="CBD5E1"/>
+            <a:srgbClr val="E2E8F0"/>
           </a:solidFill>
           <a:ln>
             <a:solidFill>
-              <a:srgbClr val="CBD5E1"/>
+              <a:srgbClr val="E2E8F0"/>
             </a:solidFill>
           </a:ln>
         </p:spPr>
@@ -6400,10 +6364,8 @@
           <a:prstGeom prst="roundRect">
             <a:avLst/>
           </a:prstGeom>
-          <a:solidFill>
-            <a:srgbClr val="FFFFFF"/>
-          </a:solidFill>
-          <a:ln>
+          <a:noFill/>
+          <a:ln w="12700">
             <a:solidFill>
               <a:srgbClr val="CBD5E1"/>
             </a:solidFill>
@@ -6546,10 +6508,8 @@
           <a:prstGeom prst="roundRect">
             <a:avLst/>
           </a:prstGeom>
-          <a:solidFill>
-            <a:srgbClr val="FFFFFF"/>
-          </a:solidFill>
-          <a:ln>
+          <a:noFill/>
+          <a:ln w="12700">
             <a:solidFill>
               <a:srgbClr val="CBD5E1"/>
             </a:solidFill>
@@ -6711,7 +6671,7 @@
             <a:avLst/>
           </a:prstGeom>
           <a:solidFill>
-            <a:srgbClr val="F8FAFC"/>
+            <a:srgbClr val="FFFFFF"/>
           </a:solidFill>
           <a:ln>
             <a:noFill/>
@@ -6824,11 +6784,11 @@
             <a:avLst/>
           </a:prstGeom>
           <a:solidFill>
-            <a:srgbClr val="CBD5E1"/>
+            <a:srgbClr val="E2E8F0"/>
           </a:solidFill>
           <a:ln>
             <a:solidFill>
-              <a:srgbClr val="CBD5E1"/>
+              <a:srgbClr val="E2E8F0"/>
             </a:solidFill>
           </a:ln>
         </p:spPr>
@@ -6868,10 +6828,8 @@
           <a:prstGeom prst="roundRect">
             <a:avLst/>
           </a:prstGeom>
-          <a:solidFill>
-            <a:srgbClr val="FFFFFF"/>
-          </a:solidFill>
-          <a:ln>
+          <a:noFill/>
+          <a:ln w="12700">
             <a:solidFill>
               <a:srgbClr val="CBD5E1"/>
             </a:solidFill>
@@ -6934,10 +6892,8 @@
           <a:prstGeom prst="roundRect">
             <a:avLst/>
           </a:prstGeom>
-          <a:solidFill>
-            <a:srgbClr val="FFFFFF"/>
-          </a:solidFill>
-          <a:ln>
+          <a:noFill/>
+          <a:ln w="12700">
             <a:solidFill>
               <a:srgbClr val="CBD5E1"/>
             </a:solidFill>
@@ -7000,10 +6956,8 @@
           <a:prstGeom prst="roundRect">
             <a:avLst/>
           </a:prstGeom>
-          <a:solidFill>
-            <a:srgbClr val="FFFFFF"/>
-          </a:solidFill>
-          <a:ln>
+          <a:noFill/>
+          <a:ln w="12700">
             <a:solidFill>
               <a:srgbClr val="CBD5E1"/>
             </a:solidFill>
@@ -7066,10 +7020,8 @@
           <a:prstGeom prst="roundRect">
             <a:avLst/>
           </a:prstGeom>
-          <a:solidFill>
-            <a:srgbClr val="FFFFFF"/>
-          </a:solidFill>
-          <a:ln>
+          <a:noFill/>
+          <a:ln w="12700">
             <a:solidFill>
               <a:srgbClr val="CBD5E1"/>
             </a:solidFill>
@@ -7132,10 +7084,8 @@
           <a:prstGeom prst="roundRect">
             <a:avLst/>
           </a:prstGeom>
-          <a:solidFill>
-            <a:srgbClr val="FFFFFF"/>
-          </a:solidFill>
-          <a:ln>
+          <a:noFill/>
+          <a:ln w="12700">
             <a:solidFill>
               <a:srgbClr val="CBD5E1"/>
             </a:solidFill>
@@ -7217,7 +7167,7 @@
             <a:avLst/>
           </a:prstGeom>
           <a:solidFill>
-            <a:srgbClr val="F8FAFC"/>
+            <a:srgbClr val="FFFFFF"/>
           </a:solidFill>
           <a:ln>
             <a:noFill/>
@@ -7330,11 +7280,11 @@
             <a:avLst/>
           </a:prstGeom>
           <a:solidFill>
-            <a:srgbClr val="CBD5E1"/>
+            <a:srgbClr val="E2E8F0"/>
           </a:solidFill>
           <a:ln>
             <a:solidFill>
-              <a:srgbClr val="CBD5E1"/>
+              <a:srgbClr val="E2E8F0"/>
             </a:solidFill>
           </a:ln>
         </p:spPr>
@@ -7374,10 +7324,8 @@
           <a:prstGeom prst="roundRect">
             <a:avLst/>
           </a:prstGeom>
-          <a:solidFill>
-            <a:srgbClr val="FFFFFF"/>
-          </a:solidFill>
-          <a:ln>
+          <a:noFill/>
+          <a:ln w="12700">
             <a:solidFill>
               <a:srgbClr val="CBD5E1"/>
             </a:solidFill>
@@ -7614,10 +7562,8 @@
           <a:prstGeom prst="roundRect">
             <a:avLst/>
           </a:prstGeom>
-          <a:solidFill>
-            <a:srgbClr val="FFFFFF"/>
-          </a:solidFill>
-          <a:ln>
+          <a:noFill/>
+          <a:ln w="12700">
             <a:solidFill>
               <a:srgbClr val="CBD5E1"/>
             </a:solidFill>
@@ -7873,7 +7819,7 @@
             <a:avLst/>
           </a:prstGeom>
           <a:solidFill>
-            <a:srgbClr val="F8FAFC"/>
+            <a:srgbClr val="FFFFFF"/>
           </a:solidFill>
           <a:ln>
             <a:noFill/>
@@ -7986,11 +7932,11 @@
             <a:avLst/>
           </a:prstGeom>
           <a:solidFill>
-            <a:srgbClr val="CBD5E1"/>
+            <a:srgbClr val="E2E8F0"/>
           </a:solidFill>
           <a:ln>
             <a:solidFill>
-              <a:srgbClr val="CBD5E1"/>
+              <a:srgbClr val="E2E8F0"/>
             </a:solidFill>
           </a:ln>
         </p:spPr>
@@ -8129,9 +8075,7 @@
                     </a:p>
                   </a:txBody>
                   <a:tcPr>
-                    <a:solidFill>
-                      <a:srgbClr val="FFFFFF"/>
-                    </a:solidFill>
+                    <a:noFill/>
                   </a:tcPr>
                 </a:tc>
                 <a:tc>
@@ -8152,9 +8096,7 @@
                     </a:p>
                   </a:txBody>
                   <a:tcPr>
-                    <a:solidFill>
-                      <a:srgbClr val="FFFFFF"/>
-                    </a:solidFill>
+                    <a:noFill/>
                   </a:tcPr>
                 </a:tc>
                 <a:tc>
@@ -8175,9 +8117,7 @@
                     </a:p>
                   </a:txBody>
                   <a:tcPr>
-                    <a:solidFill>
-                      <a:srgbClr val="FFFFFF"/>
-                    </a:solidFill>
+                    <a:noFill/>
                   </a:tcPr>
                 </a:tc>
               </a:tr>
@@ -8200,9 +8140,7 @@
                     </a:p>
                   </a:txBody>
                   <a:tcPr>
-                    <a:solidFill>
-                      <a:srgbClr val="F1F5F9"/>
-                    </a:solidFill>
+                    <a:noFill/>
                   </a:tcPr>
                 </a:tc>
                 <a:tc>
@@ -8223,9 +8161,7 @@
                     </a:p>
                   </a:txBody>
                   <a:tcPr>
-                    <a:solidFill>
-                      <a:srgbClr val="F1F5F9"/>
-                    </a:solidFill>
+                    <a:noFill/>
                   </a:tcPr>
                 </a:tc>
                 <a:tc>
@@ -8246,9 +8182,7 @@
                     </a:p>
                   </a:txBody>
                   <a:tcPr>
-                    <a:solidFill>
-                      <a:srgbClr val="F1F5F9"/>
-                    </a:solidFill>
+                    <a:noFill/>
                   </a:tcPr>
                 </a:tc>
               </a:tr>
@@ -8271,9 +8205,7 @@
                     </a:p>
                   </a:txBody>
                   <a:tcPr>
-                    <a:solidFill>
-                      <a:srgbClr val="FFFFFF"/>
-                    </a:solidFill>
+                    <a:noFill/>
                   </a:tcPr>
                 </a:tc>
                 <a:tc>
@@ -8294,9 +8226,7 @@
                     </a:p>
                   </a:txBody>
                   <a:tcPr>
-                    <a:solidFill>
-                      <a:srgbClr val="FFFFFF"/>
-                    </a:solidFill>
+                    <a:noFill/>
                   </a:tcPr>
                 </a:tc>
                 <a:tc>
@@ -8317,9 +8247,7 @@
                     </a:p>
                   </a:txBody>
                   <a:tcPr>
-                    <a:solidFill>
-                      <a:srgbClr val="FFFFFF"/>
-                    </a:solidFill>
+                    <a:noFill/>
                   </a:tcPr>
                 </a:tc>
               </a:tr>
@@ -8342,9 +8270,7 @@
                     </a:p>
                   </a:txBody>
                   <a:tcPr>
-                    <a:solidFill>
-                      <a:srgbClr val="F1F5F9"/>
-                    </a:solidFill>
+                    <a:noFill/>
                   </a:tcPr>
                 </a:tc>
                 <a:tc>
@@ -8365,9 +8291,7 @@
                     </a:p>
                   </a:txBody>
                   <a:tcPr>
-                    <a:solidFill>
-                      <a:srgbClr val="F1F5F9"/>
-                    </a:solidFill>
+                    <a:noFill/>
                   </a:tcPr>
                 </a:tc>
                 <a:tc>
@@ -8388,9 +8312,7 @@
                     </a:p>
                   </a:txBody>
                   <a:tcPr>
-                    <a:solidFill>
-                      <a:srgbClr val="F1F5F9"/>
-                    </a:solidFill>
+                    <a:noFill/>
                   </a:tcPr>
                 </a:tc>
               </a:tr>
@@ -8413,9 +8335,7 @@
                     </a:p>
                   </a:txBody>
                   <a:tcPr>
-                    <a:solidFill>
-                      <a:srgbClr val="FFFFFF"/>
-                    </a:solidFill>
+                    <a:noFill/>
                   </a:tcPr>
                 </a:tc>
                 <a:tc>
@@ -8436,9 +8356,7 @@
                     </a:p>
                   </a:txBody>
                   <a:tcPr>
-                    <a:solidFill>
-                      <a:srgbClr val="FFFFFF"/>
-                    </a:solidFill>
+                    <a:noFill/>
                   </a:tcPr>
                 </a:tc>
                 <a:tc>
@@ -8459,9 +8377,7 @@
                     </a:p>
                   </a:txBody>
                   <a:tcPr>
-                    <a:solidFill>
-                      <a:srgbClr val="FFFFFF"/>
-                    </a:solidFill>
+                    <a:noFill/>
                   </a:tcPr>
                 </a:tc>
               </a:tr>
@@ -8484,9 +8400,7 @@
                     </a:p>
                   </a:txBody>
                   <a:tcPr>
-                    <a:solidFill>
-                      <a:srgbClr val="F1F5F9"/>
-                    </a:solidFill>
+                    <a:noFill/>
                   </a:tcPr>
                 </a:tc>
                 <a:tc>
@@ -8507,9 +8421,7 @@
                     </a:p>
                   </a:txBody>
                   <a:tcPr>
-                    <a:solidFill>
-                      <a:srgbClr val="F1F5F9"/>
-                    </a:solidFill>
+                    <a:noFill/>
                   </a:tcPr>
                 </a:tc>
                 <a:tc>
@@ -8530,9 +8442,7 @@
                     </a:p>
                   </a:txBody>
                   <a:tcPr>
-                    <a:solidFill>
-                      <a:srgbClr val="F1F5F9"/>
-                    </a:solidFill>
+                    <a:noFill/>
                   </a:tcPr>
                 </a:tc>
               </a:tr>
@@ -8555,9 +8465,7 @@
                     </a:p>
                   </a:txBody>
                   <a:tcPr>
-                    <a:solidFill>
-                      <a:srgbClr val="FFFFFF"/>
-                    </a:solidFill>
+                    <a:noFill/>
                   </a:tcPr>
                 </a:tc>
                 <a:tc>
@@ -8578,9 +8486,7 @@
                     </a:p>
                   </a:txBody>
                   <a:tcPr>
-                    <a:solidFill>
-                      <a:srgbClr val="FFFFFF"/>
-                    </a:solidFill>
+                    <a:noFill/>
                   </a:tcPr>
                 </a:tc>
                 <a:tc>
@@ -8601,9 +8507,7 @@
                     </a:p>
                   </a:txBody>
                   <a:tcPr>
-                    <a:solidFill>
-                      <a:srgbClr val="FFFFFF"/>
-                    </a:solidFill>
+                    <a:noFill/>
                   </a:tcPr>
                 </a:tc>
               </a:tr>
@@ -8626,9 +8530,7 @@
                     </a:p>
                   </a:txBody>
                   <a:tcPr>
-                    <a:solidFill>
-                      <a:srgbClr val="F1F5F9"/>
-                    </a:solidFill>
+                    <a:noFill/>
                   </a:tcPr>
                 </a:tc>
                 <a:tc>
@@ -8649,9 +8551,7 @@
                     </a:p>
                   </a:txBody>
                   <a:tcPr>
-                    <a:solidFill>
-                      <a:srgbClr val="F1F5F9"/>
-                    </a:solidFill>
+                    <a:noFill/>
                   </a:tcPr>
                 </a:tc>
                 <a:tc>
@@ -8672,9 +8572,7 @@
                     </a:p>
                   </a:txBody>
                   <a:tcPr>
-                    <a:solidFill>
-                      <a:srgbClr val="F1F5F9"/>
-                    </a:solidFill>
+                    <a:noFill/>
                   </a:tcPr>
                 </a:tc>
               </a:tr>
@@ -8697,9 +8595,7 @@
                     </a:p>
                   </a:txBody>
                   <a:tcPr>
-                    <a:solidFill>
-                      <a:srgbClr val="FFFFFF"/>
-                    </a:solidFill>
+                    <a:noFill/>
                   </a:tcPr>
                 </a:tc>
                 <a:tc>
@@ -8720,9 +8616,7 @@
                     </a:p>
                   </a:txBody>
                   <a:tcPr>
-                    <a:solidFill>
-                      <a:srgbClr val="FFFFFF"/>
-                    </a:solidFill>
+                    <a:noFill/>
                   </a:tcPr>
                 </a:tc>
                 <a:tc>
@@ -8743,9 +8637,7 @@
                     </a:p>
                   </a:txBody>
                   <a:tcPr>
-                    <a:solidFill>
-                      <a:srgbClr val="FFFFFF"/>
-                    </a:solidFill>
+                    <a:noFill/>
                   </a:tcPr>
                 </a:tc>
               </a:tr>
@@ -8768,9 +8660,7 @@
                     </a:p>
                   </a:txBody>
                   <a:tcPr>
-                    <a:solidFill>
-                      <a:srgbClr val="F1F5F9"/>
-                    </a:solidFill>
+                    <a:noFill/>
                   </a:tcPr>
                 </a:tc>
                 <a:tc>
@@ -8791,9 +8681,7 @@
                     </a:p>
                   </a:txBody>
                   <a:tcPr>
-                    <a:solidFill>
-                      <a:srgbClr val="F1F5F9"/>
-                    </a:solidFill>
+                    <a:noFill/>
                   </a:tcPr>
                 </a:tc>
                 <a:tc>
@@ -8814,9 +8702,7 @@
                     </a:p>
                   </a:txBody>
                   <a:tcPr>
-                    <a:solidFill>
-                      <a:srgbClr val="F1F5F9"/>
-                    </a:solidFill>
+                    <a:noFill/>
                   </a:tcPr>
                 </a:tc>
               </a:tr>
@@ -8839,9 +8725,7 @@
                     </a:p>
                   </a:txBody>
                   <a:tcPr>
-                    <a:solidFill>
-                      <a:srgbClr val="FFFFFF"/>
-                    </a:solidFill>
+                    <a:noFill/>
                   </a:tcPr>
                 </a:tc>
                 <a:tc>
@@ -8862,9 +8746,7 @@
                     </a:p>
                   </a:txBody>
                   <a:tcPr>
-                    <a:solidFill>
-                      <a:srgbClr val="FFFFFF"/>
-                    </a:solidFill>
+                    <a:noFill/>
                   </a:tcPr>
                 </a:tc>
                 <a:tc>
@@ -8885,9 +8767,7 @@
                     </a:p>
                   </a:txBody>
                   <a:tcPr>
-                    <a:solidFill>
-                      <a:srgbClr val="FFFFFF"/>
-                    </a:solidFill>
+                    <a:noFill/>
                   </a:tcPr>
                 </a:tc>
               </a:tr>
@@ -8909,10 +8789,8 @@
           <a:prstGeom prst="roundRect">
             <a:avLst/>
           </a:prstGeom>
-          <a:solidFill>
-            <a:srgbClr val="FFFFFF"/>
-          </a:solidFill>
-          <a:ln>
+          <a:noFill/>
+          <a:ln w="12700">
             <a:solidFill>
               <a:srgbClr val="CBD5E1"/>
             </a:solidFill>
@@ -9028,7 +8906,7 @@
               </a:defRPr>
             </a:pPr>
             <a:r>
-              <a:t>Core Takeaway for viva: </a:t>
+              <a:t>Core Takeaway: </a:t>
             </a:r>
             <a:r>
               <a:rPr b="0">
@@ -9074,7 +8952,7 @@
             <a:avLst/>
           </a:prstGeom>
           <a:solidFill>
-            <a:srgbClr val="F8FAFC"/>
+            <a:srgbClr val="FFFFFF"/>
           </a:solidFill>
           <a:ln>
             <a:noFill/>
@@ -9187,11 +9065,11 @@
             <a:avLst/>
           </a:prstGeom>
           <a:solidFill>
-            <a:srgbClr val="CBD5E1"/>
+            <a:srgbClr val="E2E8F0"/>
           </a:solidFill>
           <a:ln>
             <a:solidFill>
-              <a:srgbClr val="CBD5E1"/>
+              <a:srgbClr val="E2E8F0"/>
             </a:solidFill>
           </a:ln>
         </p:spPr>
@@ -9231,10 +9109,8 @@
           <a:prstGeom prst="roundRect">
             <a:avLst/>
           </a:prstGeom>
-          <a:solidFill>
-            <a:srgbClr val="FFFFFF"/>
-          </a:solidFill>
-          <a:ln>
+          <a:noFill/>
+          <a:ln w="12700">
             <a:solidFill>
               <a:srgbClr val="CBD5E1"/>
             </a:solidFill>
@@ -9297,10 +9173,8 @@
           <a:prstGeom prst="roundRect">
             <a:avLst/>
           </a:prstGeom>
-          <a:solidFill>
-            <a:srgbClr val="FFFFFF"/>
-          </a:solidFill>
-          <a:ln>
+          <a:noFill/>
+          <a:ln w="12700">
             <a:solidFill>
               <a:srgbClr val="CBD5E1"/>
             </a:solidFill>
@@ -9363,10 +9237,8 @@
           <a:prstGeom prst="roundRect">
             <a:avLst/>
           </a:prstGeom>
-          <a:solidFill>
-            <a:srgbClr val="FFFFFF"/>
-          </a:solidFill>
-          <a:ln>
+          <a:noFill/>
+          <a:ln w="12700">
             <a:solidFill>
               <a:srgbClr val="CBD5E1"/>
             </a:solidFill>
@@ -9429,10 +9301,8 @@
           <a:prstGeom prst="roundRect">
             <a:avLst/>
           </a:prstGeom>
-          <a:solidFill>
-            <a:srgbClr val="FFFFFF"/>
-          </a:solidFill>
-          <a:ln>
+          <a:noFill/>
+          <a:ln w="12700">
             <a:solidFill>
               <a:srgbClr val="CBD5E1"/>
             </a:solidFill>
@@ -9495,10 +9365,8 @@
           <a:prstGeom prst="roundRect">
             <a:avLst/>
           </a:prstGeom>
-          <a:solidFill>
-            <a:srgbClr val="FFFFFF"/>
-          </a:solidFill>
-          <a:ln>
+          <a:noFill/>
+          <a:ln w="12700">
             <a:solidFill>
               <a:srgbClr val="CBD5E1"/>
             </a:solidFill>
@@ -9561,10 +9429,8 @@
           <a:prstGeom prst="roundRect">
             <a:avLst/>
           </a:prstGeom>
-          <a:solidFill>
-            <a:srgbClr val="FFFFFF"/>
-          </a:solidFill>
-          <a:ln>
+          <a:noFill/>
+          <a:ln w="12700">
             <a:solidFill>
               <a:srgbClr val="CBD5E1"/>
             </a:solidFill>

</xml_diff>